<commit_message>
Fix layout density and a number-range RTL bug
Several content cards across the deck (goals, research scope, timeline,
forum-experience cards) pinned text to the top and left large empty
areas below — tightened card heights, vertically centered short card
content, and pulled closing bands up to remove dead space. Also fixed
a reversed numeral range ("150-100" instead of "100-150") on the forum
info dashboard, and rebalanced the research-scope chip columns so
uneven chip counts no longer look lopsided.
Co-Authored-By: Claude Sonnet 5 <noreply@anthropic.com>
Claude-Session: https://claude.ai/code/session_01McVGqVzyuMygBm1iT7PVHW
</commit_message>
<xml_diff>
--- a/docs/presentations/research-incubator-initiative.pptx
+++ b/docs/presentations/research-incubator-initiative.pptx
@@ -144,14 +144,14 @@
   <p:extLst>
     <p:ext uri="{521415D9-36F7-43E2-AB2F-B90AF26B5E84}">
       <ns0:sectionLst xmlns:ns0="http://schemas.microsoft.com/office/powerpoint/2010/main">
-        <ns0:section name="Default Section" id="{8F762C06-98B4-4E8E-A27D-60C8A4334689}">
+        <ns0:section name="Default Section" id="{26AE289A-35DA-4CE3-8959-DBBC56DEA9DA}">
           <ns0:sldIdLst>
             <ns0:sldId id="350"/>
             <ns0:sldId id="351"/>
             <ns0:sldId id="352"/>
           </ns0:sldIdLst>
         </ns0:section>
-        <ns0:section name="القسم الأول: حاضنة الأبحاث" id="{5E977A6A-945B-491F-9F22-0ECE97280F8A}">
+        <ns0:section name="القسم الأول: حاضنة الأبحاث" id="{8E0DCF9C-05AC-4687-9C75-D33071168BCD}">
           <ns0:sldIdLst>
             <ns0:sldId id="353"/>
             <ns0:sldId id="354"/>
@@ -166,7 +166,7 @@
             <ns0:sldId id="363"/>
           </ns0:sldIdLst>
         </ns0:section>
-        <ns0:section name="القسم الثاني: ملتقى البحث والابتكار الحكومي" id="{B080CB8C-3C1C-4555-B643-BBC1F6E316BB}">
+        <ns0:section name="القسم الثاني: ملتقى البحث والابتكار الحكومي" id="{EB798F3C-7D5F-4688-8BAE-40D814914669}">
           <ns0:sldIdLst>
             <ns0:sldId id="364"/>
             <ns0:sldId id="365"/>
@@ -179,13 +179,13 @@
             <ns0:sldId id="372"/>
           </ns0:sldIdLst>
         </ns0:section>
-        <ns0:section name="القسم الثالث: القرار المطلوب" id="{7A6990B5-60CE-4444-B8ED-76CCE3959532}">
+        <ns0:section name="القسم الثالث: القرار المطلوب" id="{C4255B07-9565-4635-B8BA-25F274FA8BEF}">
           <ns0:sldIdLst>
             <ns0:sldId id="373"/>
             <ns0:sldId id="374"/>
           </ns0:sldIdLst>
         </ns0:section>
-        <ns0:section name="الملحق" id="{F65BE849-4F8F-4D87-87A0-F2A5BFCB0779}">
+        <ns0:section name="الملحق" id="{9AECEE73-9E93-4185-B8E7-A24CAA00BB54}">
           <ns0:sldIdLst>
             <ns0:sldId id="375"/>
             <ns0:sldId id="376"/>
@@ -7979,11 +7979,11 @@
         <p:spPr>
           <a:xfrm>
             <a:off x="5061204" y="1051560"/>
-            <a:ext cx="1495044" cy="1965960"/>
+            <a:ext cx="1495044" cy="1417320"/>
           </a:xfrm>
           <a:prstGeom prst="roundRect">
             <a:avLst>
-              <a:gd name="adj" fmla="val 2418"/>
+              <a:gd name="adj" fmla="val 3354"/>
             </a:avLst>
           </a:prstGeom>
           <a:solidFill>
@@ -8085,7 +8085,7 @@
         </p:nvSpPr>
         <p:spPr>
           <a:xfrm>
-            <a:off x="5180076" y="1197864"/>
+            <a:off x="5180076" y="1549908"/>
             <a:ext cx="1257300" cy="146304"/>
           </a:xfrm>
           <a:prstGeom prst="rect">
@@ -8127,8 +8127,8 @@
         </p:nvSpPr>
         <p:spPr>
           <a:xfrm>
-            <a:off x="5180076" y="1453896"/>
-            <a:ext cx="1257300" cy="1444752"/>
+            <a:off x="5180076" y="1805940"/>
+            <a:ext cx="1257300" cy="544068"/>
           </a:xfrm>
           <a:prstGeom prst="rect">
             <a:avLst/>
@@ -8170,11 +8170,11 @@
         <p:spPr>
           <a:xfrm>
             <a:off x="3474720" y="1051560"/>
-            <a:ext cx="1495044" cy="1965960"/>
+            <a:ext cx="1495044" cy="1417320"/>
           </a:xfrm>
           <a:prstGeom prst="roundRect">
             <a:avLst>
-              <a:gd name="adj" fmla="val 2418"/>
+              <a:gd name="adj" fmla="val 3354"/>
             </a:avLst>
           </a:prstGeom>
           <a:solidFill>
@@ -8276,7 +8276,7 @@
         </p:nvSpPr>
         <p:spPr>
           <a:xfrm>
-            <a:off x="3593592" y="1197864"/>
+            <a:off x="3593592" y="1549908"/>
             <a:ext cx="1257300" cy="146304"/>
           </a:xfrm>
           <a:prstGeom prst="rect">
@@ -8318,8 +8318,8 @@
         </p:nvSpPr>
         <p:spPr>
           <a:xfrm>
-            <a:off x="3593592" y="1453896"/>
-            <a:ext cx="1257300" cy="1444752"/>
+            <a:off x="3593592" y="1805940"/>
+            <a:ext cx="1257300" cy="544068"/>
           </a:xfrm>
           <a:prstGeom prst="rect">
             <a:avLst/>
@@ -8361,11 +8361,11 @@
         <p:spPr>
           <a:xfrm>
             <a:off x="1888236" y="1051560"/>
-            <a:ext cx="1495044" cy="1965960"/>
+            <a:ext cx="1495044" cy="1417320"/>
           </a:xfrm>
           <a:prstGeom prst="roundRect">
             <a:avLst>
-              <a:gd name="adj" fmla="val 2418"/>
+              <a:gd name="adj" fmla="val 3354"/>
             </a:avLst>
           </a:prstGeom>
           <a:solidFill>
@@ -8467,7 +8467,7 @@
         </p:nvSpPr>
         <p:spPr>
           <a:xfrm>
-            <a:off x="2007108" y="1197864"/>
+            <a:off x="2007108" y="1549908"/>
             <a:ext cx="1257300" cy="146304"/>
           </a:xfrm>
           <a:prstGeom prst="rect">
@@ -8509,8 +8509,8 @@
         </p:nvSpPr>
         <p:spPr>
           <a:xfrm>
-            <a:off x="2007108" y="1453896"/>
-            <a:ext cx="1257300" cy="1444752"/>
+            <a:off x="2007108" y="1805940"/>
+            <a:ext cx="1257300" cy="544068"/>
           </a:xfrm>
           <a:prstGeom prst="rect">
             <a:avLst/>
@@ -8552,11 +8552,11 @@
         <p:spPr>
           <a:xfrm>
             <a:off x="301752" y="1051560"/>
-            <a:ext cx="1495044" cy="1965960"/>
+            <a:ext cx="1495044" cy="1417320"/>
           </a:xfrm>
           <a:prstGeom prst="roundRect">
             <a:avLst>
-              <a:gd name="adj" fmla="val 2418"/>
+              <a:gd name="adj" fmla="val 3354"/>
             </a:avLst>
           </a:prstGeom>
           <a:solidFill>
@@ -8658,7 +8658,7 @@
         </p:nvSpPr>
         <p:spPr>
           <a:xfrm>
-            <a:off x="420624" y="1197864"/>
+            <a:off x="420624" y="1549908"/>
             <a:ext cx="1257300" cy="146304"/>
           </a:xfrm>
           <a:prstGeom prst="rect">
@@ -8700,8 +8700,8 @@
         </p:nvSpPr>
         <p:spPr>
           <a:xfrm>
-            <a:off x="420624" y="1453896"/>
-            <a:ext cx="1257300" cy="1444752"/>
+            <a:off x="420624" y="1805940"/>
+            <a:ext cx="1257300" cy="544068"/>
           </a:xfrm>
           <a:prstGeom prst="rect">
             <a:avLst/>
@@ -8742,8 +8742,8 @@
         </p:nvSpPr>
         <p:spPr>
           <a:xfrm>
-            <a:off x="301752" y="3246120"/>
-            <a:ext cx="6254496" cy="292608"/>
+            <a:off x="301752" y="2651760"/>
+            <a:ext cx="6254496" cy="310896"/>
           </a:xfrm>
           <a:prstGeom prst="roundRect">
             <a:avLst>
@@ -8806,8 +8806,8 @@
         </p:nvSpPr>
         <p:spPr>
           <a:xfrm>
-            <a:off x="484632" y="3246120"/>
-            <a:ext cx="5888736" cy="292608"/>
+            <a:off x="484632" y="2651760"/>
+            <a:ext cx="5888736" cy="310896"/>
           </a:xfrm>
           <a:prstGeom prst="rect">
             <a:avLst/>
@@ -10707,11 +10707,11 @@
         <p:spPr>
           <a:xfrm>
             <a:off x="4568952" y="1234440"/>
-            <a:ext cx="1987296" cy="1481328"/>
+            <a:ext cx="1987296" cy="1417320"/>
           </a:xfrm>
           <a:prstGeom prst="roundRect">
             <a:avLst>
-              <a:gd name="adj" fmla="val 3209"/>
+              <a:gd name="adj" fmla="val 3354"/>
             </a:avLst>
           </a:prstGeom>
           <a:solidFill>
@@ -10852,7 +10852,7 @@
         </p:nvSpPr>
         <p:spPr>
           <a:xfrm>
-            <a:off x="4696968" y="1581912"/>
+            <a:off x="4696968" y="1604772"/>
             <a:ext cx="1731264" cy="164592"/>
           </a:xfrm>
           <a:prstGeom prst="roundRect">
@@ -10901,7 +10901,7 @@
         </p:nvSpPr>
         <p:spPr>
           <a:xfrm>
-            <a:off x="4696968" y="1581912"/>
+            <a:off x="4696968" y="1604772"/>
             <a:ext cx="1731264" cy="164592"/>
           </a:xfrm>
           <a:prstGeom prst="rect">
@@ -10940,7 +10940,7 @@
         </p:nvSpPr>
         <p:spPr>
           <a:xfrm>
-            <a:off x="4696968" y="1801368"/>
+            <a:off x="4696968" y="1824228"/>
             <a:ext cx="1731264" cy="164592"/>
           </a:xfrm>
           <a:prstGeom prst="roundRect">
@@ -10989,7 +10989,7 @@
         </p:nvSpPr>
         <p:spPr>
           <a:xfrm>
-            <a:off x="4696968" y="1801368"/>
+            <a:off x="4696968" y="1824228"/>
             <a:ext cx="1731264" cy="164592"/>
           </a:xfrm>
           <a:prstGeom prst="rect">
@@ -11028,7 +11028,7 @@
         </p:nvSpPr>
         <p:spPr>
           <a:xfrm>
-            <a:off x="4696968" y="2020824"/>
+            <a:off x="4696968" y="2043684"/>
             <a:ext cx="1731264" cy="164592"/>
           </a:xfrm>
           <a:prstGeom prst="roundRect">
@@ -11077,7 +11077,7 @@
         </p:nvSpPr>
         <p:spPr>
           <a:xfrm>
-            <a:off x="4696968" y="2020824"/>
+            <a:off x="4696968" y="2043684"/>
             <a:ext cx="1731264" cy="164592"/>
           </a:xfrm>
           <a:prstGeom prst="rect">
@@ -11116,7 +11116,7 @@
         </p:nvSpPr>
         <p:spPr>
           <a:xfrm>
-            <a:off x="4696968" y="2240280"/>
+            <a:off x="4696968" y="2263140"/>
             <a:ext cx="1731264" cy="164592"/>
           </a:xfrm>
           <a:prstGeom prst="roundRect">
@@ -11165,7 +11165,7 @@
         </p:nvSpPr>
         <p:spPr>
           <a:xfrm>
-            <a:off x="4696968" y="2240280"/>
+            <a:off x="4696968" y="2263140"/>
             <a:ext cx="1731264" cy="164592"/>
           </a:xfrm>
           <a:prstGeom prst="rect">
@@ -11205,11 +11205,11 @@
         <p:spPr>
           <a:xfrm>
             <a:off x="2435352" y="1234440"/>
-            <a:ext cx="1987296" cy="1481328"/>
+            <a:ext cx="1987296" cy="1417320"/>
           </a:xfrm>
           <a:prstGeom prst="roundRect">
             <a:avLst>
-              <a:gd name="adj" fmla="val 3209"/>
+              <a:gd name="adj" fmla="val 3354"/>
             </a:avLst>
           </a:prstGeom>
           <a:solidFill>
@@ -11350,7 +11350,7 @@
         </p:nvSpPr>
         <p:spPr>
           <a:xfrm>
-            <a:off x="2563368" y="1581912"/>
+            <a:off x="2563368" y="1714500"/>
             <a:ext cx="1731264" cy="164592"/>
           </a:xfrm>
           <a:prstGeom prst="roundRect">
@@ -11399,7 +11399,7 @@
         </p:nvSpPr>
         <p:spPr>
           <a:xfrm>
-            <a:off x="2563368" y="1581912"/>
+            <a:off x="2563368" y="1714500"/>
             <a:ext cx="1731264" cy="164592"/>
           </a:xfrm>
           <a:prstGeom prst="rect">
@@ -11438,7 +11438,7 @@
         </p:nvSpPr>
         <p:spPr>
           <a:xfrm>
-            <a:off x="2563368" y="1801368"/>
+            <a:off x="2563368" y="1933956"/>
             <a:ext cx="1731264" cy="164592"/>
           </a:xfrm>
           <a:prstGeom prst="roundRect">
@@ -11487,7 +11487,7 @@
         </p:nvSpPr>
         <p:spPr>
           <a:xfrm>
-            <a:off x="2563368" y="1801368"/>
+            <a:off x="2563368" y="1933956"/>
             <a:ext cx="1731264" cy="164592"/>
           </a:xfrm>
           <a:prstGeom prst="rect">
@@ -11526,7 +11526,7 @@
         </p:nvSpPr>
         <p:spPr>
           <a:xfrm>
-            <a:off x="2563368" y="2020824"/>
+            <a:off x="2563368" y="2153412"/>
             <a:ext cx="1731264" cy="164592"/>
           </a:xfrm>
           <a:prstGeom prst="roundRect">
@@ -11575,7 +11575,7 @@
         </p:nvSpPr>
         <p:spPr>
           <a:xfrm>
-            <a:off x="2563368" y="2020824"/>
+            <a:off x="2563368" y="2153412"/>
             <a:ext cx="1731264" cy="164592"/>
           </a:xfrm>
           <a:prstGeom prst="rect">
@@ -11615,11 +11615,11 @@
         <p:spPr>
           <a:xfrm>
             <a:off x="301752" y="1234440"/>
-            <a:ext cx="1987296" cy="1481328"/>
+            <a:ext cx="1987296" cy="1417320"/>
           </a:xfrm>
           <a:prstGeom prst="roundRect">
             <a:avLst>
-              <a:gd name="adj" fmla="val 3209"/>
+              <a:gd name="adj" fmla="val 3354"/>
             </a:avLst>
           </a:prstGeom>
           <a:solidFill>
@@ -11760,7 +11760,7 @@
         </p:nvSpPr>
         <p:spPr>
           <a:xfrm>
-            <a:off x="429768" y="1581912"/>
+            <a:off x="429768" y="1824228"/>
             <a:ext cx="1731264" cy="164592"/>
           </a:xfrm>
           <a:prstGeom prst="roundRect">
@@ -11809,7 +11809,7 @@
         </p:nvSpPr>
         <p:spPr>
           <a:xfrm>
-            <a:off x="429768" y="1581912"/>
+            <a:off x="429768" y="1824228"/>
             <a:ext cx="1731264" cy="164592"/>
           </a:xfrm>
           <a:prstGeom prst="rect">
@@ -11848,7 +11848,7 @@
         </p:nvSpPr>
         <p:spPr>
           <a:xfrm>
-            <a:off x="429768" y="1801368"/>
+            <a:off x="429768" y="2043684"/>
             <a:ext cx="1731264" cy="164592"/>
           </a:xfrm>
           <a:prstGeom prst="roundRect">
@@ -11897,7 +11897,7 @@
         </p:nvSpPr>
         <p:spPr>
           <a:xfrm>
-            <a:off x="429768" y="1801368"/>
+            <a:off x="429768" y="2043684"/>
             <a:ext cx="1731264" cy="164592"/>
           </a:xfrm>
           <a:prstGeom prst="rect">
@@ -11936,8 +11936,8 @@
         </p:nvSpPr>
         <p:spPr>
           <a:xfrm>
-            <a:off x="301752" y="3337560"/>
-            <a:ext cx="6254496" cy="274320"/>
+            <a:off x="301752" y="2880360"/>
+            <a:ext cx="6254496" cy="292608"/>
           </a:xfrm>
           <a:prstGeom prst="roundRect">
             <a:avLst>
@@ -12000,8 +12000,8 @@
         </p:nvSpPr>
         <p:spPr>
           <a:xfrm>
-            <a:off x="484632" y="3337560"/>
-            <a:ext cx="5888736" cy="274320"/>
+            <a:off x="484632" y="2880360"/>
+            <a:ext cx="5888736" cy="292608"/>
           </a:xfrm>
           <a:prstGeom prst="rect">
             <a:avLst/>
@@ -14526,7 +14526,7 @@
         </p:nvCxnSpPr>
         <p:spPr>
           <a:xfrm flipV="0">
-            <a:off x="301752" y="1874520"/>
+            <a:off x="301752" y="1554480"/>
             <a:ext cx="6254496" cy="914"/>
           </a:xfrm>
           <a:prstGeom prst="line">
@@ -14547,7 +14547,7 @@
         </p:nvSpPr>
         <p:spPr>
           <a:xfrm>
-            <a:off x="5445252" y="1805940"/>
+            <a:off x="5445252" y="1485900"/>
             <a:ext cx="137160" cy="137160"/>
           </a:xfrm>
           <a:prstGeom prst="ellipse">
@@ -14596,7 +14596,7 @@
         </p:nvSpPr>
         <p:spPr>
           <a:xfrm>
-            <a:off x="5479542" y="1840230"/>
+            <a:off x="5479542" y="1520190"/>
             <a:ext cx="68580" cy="68580"/>
           </a:xfrm>
           <a:prstGeom prst="ellipse">
@@ -14643,7 +14643,7 @@
         </p:nvSpPr>
         <p:spPr>
           <a:xfrm>
-            <a:off x="4517136" y="1490472"/>
+            <a:off x="4517136" y="1170432"/>
             <a:ext cx="1993392" cy="201168"/>
           </a:xfrm>
           <a:prstGeom prst="rect">
@@ -14682,7 +14682,7 @@
         </p:nvSpPr>
         <p:spPr>
           <a:xfrm>
-            <a:off x="4517136" y="2002536"/>
+            <a:off x="4517136" y="1682496"/>
             <a:ext cx="1993392" cy="137160"/>
           </a:xfrm>
           <a:prstGeom prst="rect">
@@ -14721,7 +14721,7 @@
         </p:nvSpPr>
         <p:spPr>
           <a:xfrm>
-            <a:off x="4517136" y="2148840"/>
+            <a:off x="4517136" y="1828800"/>
             <a:ext cx="1993392" cy="457200"/>
           </a:xfrm>
           <a:prstGeom prst="rect">
@@ -14763,7 +14763,7 @@
         </p:nvSpPr>
         <p:spPr>
           <a:xfrm>
-            <a:off x="3360420" y="1805940"/>
+            <a:off x="3360420" y="1485900"/>
             <a:ext cx="137160" cy="137160"/>
           </a:xfrm>
           <a:prstGeom prst="ellipse">
@@ -14812,7 +14812,7 @@
         </p:nvSpPr>
         <p:spPr>
           <a:xfrm>
-            <a:off x="3394710" y="1840230"/>
+            <a:off x="3394710" y="1520190"/>
             <a:ext cx="68580" cy="68580"/>
           </a:xfrm>
           <a:prstGeom prst="ellipse">
@@ -14859,7 +14859,7 @@
         </p:nvSpPr>
         <p:spPr>
           <a:xfrm>
-            <a:off x="2432304" y="1490472"/>
+            <a:off x="2432304" y="1170432"/>
             <a:ext cx="1993392" cy="201168"/>
           </a:xfrm>
           <a:prstGeom prst="rect">
@@ -14898,7 +14898,7 @@
         </p:nvSpPr>
         <p:spPr>
           <a:xfrm>
-            <a:off x="2432304" y="2002536"/>
+            <a:off x="2432304" y="1682496"/>
             <a:ext cx="1993392" cy="137160"/>
           </a:xfrm>
           <a:prstGeom prst="rect">
@@ -14937,7 +14937,7 @@
         </p:nvSpPr>
         <p:spPr>
           <a:xfrm>
-            <a:off x="2432304" y="2148840"/>
+            <a:off x="2432304" y="1828800"/>
             <a:ext cx="1993392" cy="457200"/>
           </a:xfrm>
           <a:prstGeom prst="rect">
@@ -14979,7 +14979,7 @@
         </p:nvSpPr>
         <p:spPr>
           <a:xfrm>
-            <a:off x="1275588" y="1805940"/>
+            <a:off x="1275588" y="1485900"/>
             <a:ext cx="137160" cy="137160"/>
           </a:xfrm>
           <a:prstGeom prst="ellipse">
@@ -15028,7 +15028,7 @@
         </p:nvSpPr>
         <p:spPr>
           <a:xfrm>
-            <a:off x="1309878" y="1840230"/>
+            <a:off x="1309878" y="1520190"/>
             <a:ext cx="68580" cy="68580"/>
           </a:xfrm>
           <a:prstGeom prst="ellipse">
@@ -15075,7 +15075,7 @@
         </p:nvSpPr>
         <p:spPr>
           <a:xfrm>
-            <a:off x="347472" y="1490472"/>
+            <a:off x="347472" y="1170432"/>
             <a:ext cx="1993392" cy="201168"/>
           </a:xfrm>
           <a:prstGeom prst="rect">
@@ -15114,7 +15114,7 @@
         </p:nvSpPr>
         <p:spPr>
           <a:xfrm>
-            <a:off x="347472" y="2002536"/>
+            <a:off x="347472" y="1682496"/>
             <a:ext cx="1993392" cy="137160"/>
           </a:xfrm>
           <a:prstGeom prst="rect">
@@ -15153,7 +15153,7 @@
         </p:nvSpPr>
         <p:spPr>
           <a:xfrm>
-            <a:off x="347472" y="2148840"/>
+            <a:off x="347472" y="1828800"/>
             <a:ext cx="1993392" cy="457200"/>
           </a:xfrm>
           <a:prstGeom prst="rect">
@@ -15195,8 +15195,8 @@
         </p:nvSpPr>
         <p:spPr>
           <a:xfrm>
-            <a:off x="301752" y="3337560"/>
-            <a:ext cx="6254496" cy="274320"/>
+            <a:off x="301752" y="2697480"/>
+            <a:ext cx="6254496" cy="310896"/>
           </a:xfrm>
           <a:prstGeom prst="roundRect">
             <a:avLst>
@@ -15259,8 +15259,8 @@
         </p:nvSpPr>
         <p:spPr>
           <a:xfrm>
-            <a:off x="484632" y="3337560"/>
-            <a:ext cx="5888736" cy="274320"/>
+            <a:off x="484632" y="2697480"/>
+            <a:ext cx="5888736" cy="310896"/>
           </a:xfrm>
           <a:prstGeom prst="rect">
             <a:avLst/>
@@ -17044,11 +17044,11 @@
         <p:spPr>
           <a:xfrm>
             <a:off x="5061204" y="1508760"/>
-            <a:ext cx="1495044" cy="1143000"/>
+            <a:ext cx="1495044" cy="1325880"/>
           </a:xfrm>
           <a:prstGeom prst="roundRect">
             <a:avLst>
-              <a:gd name="adj" fmla="val 4160"/>
+              <a:gd name="adj" fmla="val 3586"/>
             </a:avLst>
           </a:prstGeom>
           <a:solidFill>
@@ -17150,7 +17150,7 @@
         </p:nvSpPr>
         <p:spPr>
           <a:xfrm>
-            <a:off x="5180076" y="1655064"/>
+            <a:off x="5180076" y="2007108"/>
             <a:ext cx="1257300" cy="146304"/>
           </a:xfrm>
           <a:prstGeom prst="rect">
@@ -17192,8 +17192,8 @@
         </p:nvSpPr>
         <p:spPr>
           <a:xfrm>
-            <a:off x="5180076" y="1911096"/>
-            <a:ext cx="1257300" cy="621792"/>
+            <a:off x="5180076" y="2263140"/>
+            <a:ext cx="1257300" cy="452628"/>
           </a:xfrm>
           <a:prstGeom prst="rect">
             <a:avLst/>
@@ -17235,11 +17235,11 @@
         <p:spPr>
           <a:xfrm>
             <a:off x="3474720" y="1508760"/>
-            <a:ext cx="1495044" cy="1143000"/>
+            <a:ext cx="1495044" cy="1325880"/>
           </a:xfrm>
           <a:prstGeom prst="roundRect">
             <a:avLst>
-              <a:gd name="adj" fmla="val 4160"/>
+              <a:gd name="adj" fmla="val 3586"/>
             </a:avLst>
           </a:prstGeom>
           <a:solidFill>
@@ -17341,7 +17341,7 @@
         </p:nvSpPr>
         <p:spPr>
           <a:xfrm>
-            <a:off x="3593592" y="1655064"/>
+            <a:off x="3593592" y="2007108"/>
             <a:ext cx="1257300" cy="146304"/>
           </a:xfrm>
           <a:prstGeom prst="rect">
@@ -17383,8 +17383,8 @@
         </p:nvSpPr>
         <p:spPr>
           <a:xfrm>
-            <a:off x="3593592" y="1792224"/>
-            <a:ext cx="1257300" cy="740664"/>
+            <a:off x="3593592" y="2144268"/>
+            <a:ext cx="1257300" cy="571500"/>
           </a:xfrm>
           <a:prstGeom prst="rect">
             <a:avLst/>
@@ -17426,11 +17426,11 @@
         <p:spPr>
           <a:xfrm>
             <a:off x="1888236" y="1508760"/>
-            <a:ext cx="1495044" cy="1143000"/>
+            <a:ext cx="1495044" cy="1325880"/>
           </a:xfrm>
           <a:prstGeom prst="roundRect">
             <a:avLst>
-              <a:gd name="adj" fmla="val 4160"/>
+              <a:gd name="adj" fmla="val 3586"/>
             </a:avLst>
           </a:prstGeom>
           <a:solidFill>
@@ -17532,7 +17532,7 @@
         </p:nvSpPr>
         <p:spPr>
           <a:xfrm>
-            <a:off x="2007108" y="1655064"/>
+            <a:off x="2007108" y="2007108"/>
             <a:ext cx="1257300" cy="146304"/>
           </a:xfrm>
           <a:prstGeom prst="rect">
@@ -17574,8 +17574,8 @@
         </p:nvSpPr>
         <p:spPr>
           <a:xfrm>
-            <a:off x="2007108" y="1911096"/>
-            <a:ext cx="1257300" cy="621792"/>
+            <a:off x="2007108" y="2263140"/>
+            <a:ext cx="1257300" cy="452628"/>
           </a:xfrm>
           <a:prstGeom prst="rect">
             <a:avLst/>
@@ -17617,11 +17617,11 @@
         <p:spPr>
           <a:xfrm>
             <a:off x="301752" y="1508760"/>
-            <a:ext cx="1495044" cy="1143000"/>
+            <a:ext cx="1495044" cy="1325880"/>
           </a:xfrm>
           <a:prstGeom prst="roundRect">
             <a:avLst>
-              <a:gd name="adj" fmla="val 4160"/>
+              <a:gd name="adj" fmla="val 3586"/>
             </a:avLst>
           </a:prstGeom>
           <a:solidFill>
@@ -17723,7 +17723,7 @@
         </p:nvSpPr>
         <p:spPr>
           <a:xfrm>
-            <a:off x="420624" y="1655064"/>
+            <a:off x="420624" y="2007108"/>
             <a:ext cx="1257300" cy="146304"/>
           </a:xfrm>
           <a:prstGeom prst="rect">
@@ -17765,8 +17765,8 @@
         </p:nvSpPr>
         <p:spPr>
           <a:xfrm>
-            <a:off x="420624" y="1911096"/>
-            <a:ext cx="1257300" cy="621792"/>
+            <a:off x="420624" y="2263140"/>
+            <a:ext cx="1257300" cy="452628"/>
           </a:xfrm>
           <a:prstGeom prst="rect">
             <a:avLst/>
@@ -17807,8 +17807,8 @@
         </p:nvSpPr>
         <p:spPr>
           <a:xfrm>
-            <a:off x="301752" y="2834640"/>
-            <a:ext cx="6254496" cy="292608"/>
+            <a:off x="301752" y="2971800"/>
+            <a:ext cx="6254496" cy="310896"/>
           </a:xfrm>
           <a:prstGeom prst="roundRect">
             <a:avLst>
@@ -17871,8 +17871,8 @@
         </p:nvSpPr>
         <p:spPr>
           <a:xfrm>
-            <a:off x="484632" y="2834640"/>
-            <a:ext cx="5888736" cy="292608"/>
+            <a:off x="484632" y="2971800"/>
+            <a:ext cx="5888736" cy="310896"/>
           </a:xfrm>
           <a:prstGeom prst="rect">
             <a:avLst/>
@@ -18491,7 +18491,7 @@
                 <a:ea typeface="DiodrumArabic-Bold"/>
                 <a:cs typeface="DiodrumArabic-Bold"/>
               </a:rPr>
-              <a:t>150-100</a:t>
+              <a:t>100-150</a:t>
             </a:r>
           </a:p>
         </p:txBody>
@@ -18753,11 +18753,11 @@
         <p:spPr>
           <a:xfrm>
             <a:off x="5061204" y="1417320"/>
-            <a:ext cx="1495044" cy="1417320"/>
+            <a:ext cx="1495044" cy="1554480"/>
           </a:xfrm>
           <a:prstGeom prst="roundRect">
             <a:avLst>
-              <a:gd name="adj" fmla="val 3354"/>
+              <a:gd name="adj" fmla="val 3058"/>
             </a:avLst>
           </a:prstGeom>
           <a:gradFill>
@@ -18859,7 +18859,7 @@
         <p:spPr>
           <a:xfrm>
             <a:off x="5180076" y="1719072"/>
-            <a:ext cx="1257300" cy="996696"/>
+            <a:ext cx="1257300" cy="1133856"/>
           </a:xfrm>
           <a:prstGeom prst="rect">
             <a:avLst/>
@@ -18901,11 +18901,11 @@
         <p:spPr>
           <a:xfrm>
             <a:off x="3474720" y="1417320"/>
-            <a:ext cx="1495044" cy="1417320"/>
+            <a:ext cx="1495044" cy="1554480"/>
           </a:xfrm>
           <a:prstGeom prst="roundRect">
             <a:avLst>
-              <a:gd name="adj" fmla="val 3354"/>
+              <a:gd name="adj" fmla="val 3058"/>
             </a:avLst>
           </a:prstGeom>
           <a:solidFill>
@@ -19007,7 +19007,7 @@
         </p:nvSpPr>
         <p:spPr>
           <a:xfrm>
-            <a:off x="3593592" y="1563624"/>
+            <a:off x="3593592" y="2020824"/>
             <a:ext cx="1257300" cy="146304"/>
           </a:xfrm>
           <a:prstGeom prst="rect">
@@ -19049,8 +19049,8 @@
         </p:nvSpPr>
         <p:spPr>
           <a:xfrm>
-            <a:off x="3593592" y="1700784"/>
-            <a:ext cx="1257300" cy="1014984"/>
+            <a:off x="3593592" y="2157984"/>
+            <a:ext cx="1257300" cy="694944"/>
           </a:xfrm>
           <a:prstGeom prst="rect">
             <a:avLst/>
@@ -19092,11 +19092,11 @@
         <p:spPr>
           <a:xfrm>
             <a:off x="1888236" y="1417320"/>
-            <a:ext cx="1495044" cy="1417320"/>
+            <a:ext cx="1495044" cy="1554480"/>
           </a:xfrm>
           <a:prstGeom prst="roundRect">
             <a:avLst>
-              <a:gd name="adj" fmla="val 3354"/>
+              <a:gd name="adj" fmla="val 3058"/>
             </a:avLst>
           </a:prstGeom>
           <a:solidFill>
@@ -19198,7 +19198,7 @@
         </p:nvSpPr>
         <p:spPr>
           <a:xfrm>
-            <a:off x="2007108" y="1563624"/>
+            <a:off x="2007108" y="2020824"/>
             <a:ext cx="1257300" cy="146304"/>
           </a:xfrm>
           <a:prstGeom prst="rect">
@@ -19240,8 +19240,8 @@
         </p:nvSpPr>
         <p:spPr>
           <a:xfrm>
-            <a:off x="2007108" y="1700784"/>
-            <a:ext cx="1257300" cy="1014984"/>
+            <a:off x="2007108" y="2157984"/>
+            <a:ext cx="1257300" cy="694944"/>
           </a:xfrm>
           <a:prstGeom prst="rect">
             <a:avLst/>
@@ -19283,11 +19283,11 @@
         <p:spPr>
           <a:xfrm>
             <a:off x="301752" y="1417320"/>
-            <a:ext cx="1495044" cy="1417320"/>
+            <a:ext cx="1495044" cy="1554480"/>
           </a:xfrm>
           <a:prstGeom prst="roundRect">
             <a:avLst>
-              <a:gd name="adj" fmla="val 3354"/>
+              <a:gd name="adj" fmla="val 3058"/>
             </a:avLst>
           </a:prstGeom>
           <a:solidFill>
@@ -19389,7 +19389,7 @@
         </p:nvSpPr>
         <p:spPr>
           <a:xfrm>
-            <a:off x="420624" y="1563624"/>
+            <a:off x="420624" y="2020824"/>
             <a:ext cx="1257300" cy="146304"/>
           </a:xfrm>
           <a:prstGeom prst="rect">
@@ -19431,8 +19431,8 @@
         </p:nvSpPr>
         <p:spPr>
           <a:xfrm>
-            <a:off x="420624" y="1700784"/>
-            <a:ext cx="1257300" cy="1014984"/>
+            <a:off x="420624" y="2157984"/>
+            <a:ext cx="1257300" cy="694944"/>
           </a:xfrm>
           <a:prstGeom prst="rect">
             <a:avLst/>
@@ -19473,8 +19473,8 @@
         </p:nvSpPr>
         <p:spPr>
           <a:xfrm>
-            <a:off x="301752" y="2999232"/>
-            <a:ext cx="6254496" cy="274320"/>
+            <a:off x="301752" y="3136392"/>
+            <a:ext cx="6254496" cy="292608"/>
           </a:xfrm>
           <a:prstGeom prst="roundRect">
             <a:avLst>
@@ -19537,8 +19537,8 @@
         </p:nvSpPr>
         <p:spPr>
           <a:xfrm>
-            <a:off x="484632" y="2999232"/>
-            <a:ext cx="5888736" cy="274320"/>
+            <a:off x="484632" y="3136392"/>
+            <a:ext cx="5888736" cy="292608"/>
           </a:xfrm>
           <a:prstGeom prst="rect">
             <a:avLst/>
@@ -21673,11 +21673,11 @@
         <p:spPr>
           <a:xfrm>
             <a:off x="5061204" y="1417320"/>
-            <a:ext cx="1495044" cy="1188720"/>
+            <a:ext cx="1495044" cy="1371600"/>
           </a:xfrm>
           <a:prstGeom prst="roundRect">
             <a:avLst>
-              <a:gd name="adj" fmla="val 4000"/>
+              <a:gd name="adj" fmla="val 3466"/>
             </a:avLst>
           </a:prstGeom>
           <a:solidFill>
@@ -21779,7 +21779,7 @@
         </p:nvSpPr>
         <p:spPr>
           <a:xfrm>
-            <a:off x="5180076" y="1563624"/>
+            <a:off x="5180076" y="1938528"/>
             <a:ext cx="1257300" cy="146304"/>
           </a:xfrm>
           <a:prstGeom prst="rect">
@@ -21821,8 +21821,8 @@
         </p:nvSpPr>
         <p:spPr>
           <a:xfrm>
-            <a:off x="5180076" y="1700784"/>
-            <a:ext cx="1257300" cy="786384"/>
+            <a:off x="5180076" y="2075688"/>
+            <a:ext cx="1257300" cy="594360"/>
           </a:xfrm>
           <a:prstGeom prst="rect">
             <a:avLst/>
@@ -21864,11 +21864,11 @@
         <p:spPr>
           <a:xfrm>
             <a:off x="3474720" y="1417320"/>
-            <a:ext cx="1495044" cy="1188720"/>
+            <a:ext cx="1495044" cy="1371600"/>
           </a:xfrm>
           <a:prstGeom prst="roundRect">
             <a:avLst>
-              <a:gd name="adj" fmla="val 4000"/>
+              <a:gd name="adj" fmla="val 3466"/>
             </a:avLst>
           </a:prstGeom>
           <a:solidFill>
@@ -21970,7 +21970,7 @@
         </p:nvSpPr>
         <p:spPr>
           <a:xfrm>
-            <a:off x="3593592" y="1563624"/>
+            <a:off x="3593592" y="1938528"/>
             <a:ext cx="1257300" cy="146304"/>
           </a:xfrm>
           <a:prstGeom prst="rect">
@@ -22012,8 +22012,8 @@
         </p:nvSpPr>
         <p:spPr>
           <a:xfrm>
-            <a:off x="3593592" y="1700784"/>
-            <a:ext cx="1257300" cy="786384"/>
+            <a:off x="3593592" y="2075688"/>
+            <a:ext cx="1257300" cy="594360"/>
           </a:xfrm>
           <a:prstGeom prst="rect">
             <a:avLst/>
@@ -22055,11 +22055,11 @@
         <p:spPr>
           <a:xfrm>
             <a:off x="1888236" y="1417320"/>
-            <a:ext cx="1495044" cy="1188720"/>
+            <a:ext cx="1495044" cy="1371600"/>
           </a:xfrm>
           <a:prstGeom prst="roundRect">
             <a:avLst>
-              <a:gd name="adj" fmla="val 4000"/>
+              <a:gd name="adj" fmla="val 3466"/>
             </a:avLst>
           </a:prstGeom>
           <a:solidFill>
@@ -22161,7 +22161,7 @@
         </p:nvSpPr>
         <p:spPr>
           <a:xfrm>
-            <a:off x="2007108" y="1563624"/>
+            <a:off x="2007108" y="1938528"/>
             <a:ext cx="1257300" cy="146304"/>
           </a:xfrm>
           <a:prstGeom prst="rect">
@@ -22203,8 +22203,8 @@
         </p:nvSpPr>
         <p:spPr>
           <a:xfrm>
-            <a:off x="2007108" y="1700784"/>
-            <a:ext cx="1257300" cy="786384"/>
+            <a:off x="2007108" y="2075688"/>
+            <a:ext cx="1257300" cy="594360"/>
           </a:xfrm>
           <a:prstGeom prst="rect">
             <a:avLst/>
@@ -22246,11 +22246,11 @@
         <p:spPr>
           <a:xfrm>
             <a:off x="301752" y="1417320"/>
-            <a:ext cx="1495044" cy="1188720"/>
+            <a:ext cx="1495044" cy="1371600"/>
           </a:xfrm>
           <a:prstGeom prst="roundRect">
             <a:avLst>
-              <a:gd name="adj" fmla="val 4000"/>
+              <a:gd name="adj" fmla="val 3466"/>
             </a:avLst>
           </a:prstGeom>
           <a:solidFill>
@@ -22352,7 +22352,7 @@
         </p:nvSpPr>
         <p:spPr>
           <a:xfrm>
-            <a:off x="420624" y="1563624"/>
+            <a:off x="420624" y="1938528"/>
             <a:ext cx="1257300" cy="146304"/>
           </a:xfrm>
           <a:prstGeom prst="rect">
@@ -22394,8 +22394,8 @@
         </p:nvSpPr>
         <p:spPr>
           <a:xfrm>
-            <a:off x="420624" y="1700784"/>
-            <a:ext cx="1257300" cy="786384"/>
+            <a:off x="420624" y="2075688"/>
+            <a:ext cx="1257300" cy="594360"/>
           </a:xfrm>
           <a:prstGeom prst="rect">
             <a:avLst/>
@@ -22436,7 +22436,7 @@
         </p:nvSpPr>
         <p:spPr>
           <a:xfrm>
-            <a:off x="301752" y="2788920"/>
+            <a:off x="301752" y="2971800"/>
             <a:ext cx="6254496" cy="292608"/>
           </a:xfrm>
           <a:prstGeom prst="roundRect">
@@ -22500,7 +22500,7 @@
         </p:nvSpPr>
         <p:spPr>
           <a:xfrm>
-            <a:off x="484632" y="2788920"/>
+            <a:off x="484632" y="2971800"/>
             <a:ext cx="5888736" cy="292608"/>
           </a:xfrm>
           <a:prstGeom prst="rect">
@@ -34758,11 +34758,11 @@
         <p:spPr>
           <a:xfrm>
             <a:off x="301752" y="1417320"/>
-            <a:ext cx="6254496" cy="1051560"/>
+            <a:ext cx="6254496" cy="1325880"/>
           </a:xfrm>
           <a:prstGeom prst="roundRect">
             <a:avLst>
-              <a:gd name="adj" fmla="val 4521"/>
+              <a:gd name="adj" fmla="val 3586"/>
             </a:avLst>
           </a:prstGeom>
           <a:solidFill>
@@ -34816,7 +34816,7 @@
         <p:spPr>
           <a:xfrm flipV="0">
             <a:off x="4471416" y="1563624"/>
-            <a:ext cx="914" cy="758952"/>
+            <a:ext cx="914" cy="1033272"/>
           </a:xfrm>
           <a:prstGeom prst="line">
             <a:avLst/>
@@ -34836,7 +34836,7 @@
         </p:nvSpPr>
         <p:spPr>
           <a:xfrm>
-            <a:off x="6291072" y="1623060"/>
+            <a:off x="6291072" y="1906524"/>
             <a:ext cx="91440" cy="91440"/>
           </a:xfrm>
           <a:prstGeom prst="ellipse">
@@ -34885,7 +34885,7 @@
         </p:nvSpPr>
         <p:spPr>
           <a:xfrm>
-            <a:off x="4617720" y="1572768"/>
+            <a:off x="4617720" y="1856232"/>
             <a:ext cx="1664208" cy="146304"/>
           </a:xfrm>
           <a:prstGeom prst="rect">
@@ -34924,8 +34924,8 @@
         </p:nvSpPr>
         <p:spPr>
           <a:xfrm>
-            <a:off x="4617720" y="1819656"/>
-            <a:ext cx="1792224" cy="484632"/>
+            <a:off x="4617720" y="2103120"/>
+            <a:ext cx="1792224" cy="502920"/>
           </a:xfrm>
           <a:prstGeom prst="rect">
             <a:avLst/>
@@ -34967,7 +34967,7 @@
         <p:spPr>
           <a:xfrm flipV="0">
             <a:off x="2386584" y="1563624"/>
-            <a:ext cx="914" cy="758952"/>
+            <a:ext cx="914" cy="1033272"/>
           </a:xfrm>
           <a:prstGeom prst="line">
             <a:avLst/>
@@ -34987,7 +34987,7 @@
         </p:nvSpPr>
         <p:spPr>
           <a:xfrm>
-            <a:off x="4206240" y="1623060"/>
+            <a:off x="4206240" y="1906524"/>
             <a:ext cx="91440" cy="91440"/>
           </a:xfrm>
           <a:prstGeom prst="ellipse">
@@ -35034,7 +35034,7 @@
         </p:nvSpPr>
         <p:spPr>
           <a:xfrm>
-            <a:off x="2532888" y="1572768"/>
+            <a:off x="2532888" y="1856232"/>
             <a:ext cx="1664208" cy="146304"/>
           </a:xfrm>
           <a:prstGeom prst="rect">
@@ -35073,8 +35073,8 @@
         </p:nvSpPr>
         <p:spPr>
           <a:xfrm>
-            <a:off x="2532888" y="1819656"/>
-            <a:ext cx="1792224" cy="484632"/>
+            <a:off x="2532888" y="2103120"/>
+            <a:ext cx="1792224" cy="502920"/>
           </a:xfrm>
           <a:prstGeom prst="rect">
             <a:avLst/>
@@ -35115,7 +35115,7 @@
         </p:nvSpPr>
         <p:spPr>
           <a:xfrm>
-            <a:off x="2121408" y="1623060"/>
+            <a:off x="2121408" y="1906524"/>
             <a:ext cx="91440" cy="91440"/>
           </a:xfrm>
           <a:prstGeom prst="ellipse">
@@ -35162,7 +35162,7 @@
         </p:nvSpPr>
         <p:spPr>
           <a:xfrm>
-            <a:off x="448056" y="1572768"/>
+            <a:off x="448056" y="1856232"/>
             <a:ext cx="1664208" cy="146304"/>
           </a:xfrm>
           <a:prstGeom prst="rect">
@@ -35201,8 +35201,8 @@
         </p:nvSpPr>
         <p:spPr>
           <a:xfrm>
-            <a:off x="448056" y="1819656"/>
-            <a:ext cx="1792224" cy="484632"/>
+            <a:off x="448056" y="2103120"/>
+            <a:ext cx="1792224" cy="502920"/>
           </a:xfrm>
           <a:prstGeom prst="rect">
             <a:avLst/>
@@ -35243,7 +35243,7 @@
         </p:nvSpPr>
         <p:spPr>
           <a:xfrm>
-            <a:off x="301752" y="2615184"/>
+            <a:off x="301752" y="2889504"/>
             <a:ext cx="6254496" cy="274320"/>
           </a:xfrm>
           <a:prstGeom prst="rect">

</xml_diff>